<commit_message>
docs: update final presentation deck
Co-Authored-By: Claude Opus 5.5 <noreply@anthropic.com>
</commit_message>
<xml_diff>
--- a/presentation/Group_21_Slides_FinalPresentation.pptx
+++ b/presentation/Group_21_Slides_FinalPresentation.pptx
@@ -2286,7 +2286,7 @@
           <a:p>
             <a:fld id="{5BCAD085-E8A6-8845-BD4E-CB4CCA059FC4}" type="datetimeFigureOut">
               <a:rPr lang="en-US" smtClean="0"/>
-              <a:t>10/30/2026</a:t>
+              <a:t>10/31/2026</a:t>
             </a:fld>
             <a:endParaRPr lang="en-US"/>
           </a:p>
@@ -2454,7 +2454,7 @@
           <a:p>
             <a:fld id="{5BCAD085-E8A6-8845-BD4E-CB4CCA059FC4}" type="datetimeFigureOut">
               <a:rPr lang="en-US" smtClean="0"/>
-              <a:t>10/30/2026</a:t>
+              <a:t>10/31/2026</a:t>
             </a:fld>
             <a:endParaRPr lang="en-US"/>
           </a:p>
@@ -2632,7 +2632,7 @@
           <a:p>
             <a:fld id="{5BCAD085-E8A6-8845-BD4E-CB4CCA059FC4}" type="datetimeFigureOut">
               <a:rPr lang="en-US" smtClean="0"/>
-              <a:t>10/30/2026</a:t>
+              <a:t>10/31/2026</a:t>
             </a:fld>
             <a:endParaRPr lang="en-US"/>
           </a:p>
@@ -2938,7 +2938,7 @@
           <a:p>
             <a:fld id="{5BCAD085-E8A6-8845-BD4E-CB4CCA059FC4}" type="datetimeFigureOut">
               <a:rPr lang="en-US" smtClean="0"/>
-              <a:t>10/30/2026</a:t>
+              <a:t>10/31/2026</a:t>
             </a:fld>
             <a:endParaRPr lang="en-US"/>
           </a:p>
@@ -3183,7 +3183,7 @@
           <a:p>
             <a:fld id="{5BCAD085-E8A6-8845-BD4E-CB4CCA059FC4}" type="datetimeFigureOut">
               <a:rPr lang="en-US" smtClean="0"/>
-              <a:t>10/30/2026</a:t>
+              <a:t>10/31/2026</a:t>
             </a:fld>
             <a:endParaRPr lang="en-US"/>
           </a:p>
@@ -3468,7 +3468,7 @@
           <a:p>
             <a:fld id="{5BCAD085-E8A6-8845-BD4E-CB4CCA059FC4}" type="datetimeFigureOut">
               <a:rPr lang="en-US" smtClean="0"/>
-              <a:t>10/30/2026</a:t>
+              <a:t>10/31/2026</a:t>
             </a:fld>
             <a:endParaRPr lang="en-US"/>
           </a:p>
@@ -3887,7 +3887,7 @@
           <a:p>
             <a:fld id="{5BCAD085-E8A6-8845-BD4E-CB4CCA059FC4}" type="datetimeFigureOut">
               <a:rPr lang="en-US" smtClean="0"/>
-              <a:t>10/30/2026</a:t>
+              <a:t>10/31/2026</a:t>
             </a:fld>
             <a:endParaRPr lang="en-US"/>
           </a:p>
@@ -4004,7 +4004,7 @@
           <a:p>
             <a:fld id="{5BCAD085-E8A6-8845-BD4E-CB4CCA059FC4}" type="datetimeFigureOut">
               <a:rPr lang="en-US" smtClean="0"/>
-              <a:t>10/30/2026</a:t>
+              <a:t>10/31/2026</a:t>
             </a:fld>
             <a:endParaRPr lang="en-US"/>
           </a:p>
@@ -4099,7 +4099,7 @@
           <a:p>
             <a:fld id="{5BCAD085-E8A6-8845-BD4E-CB4CCA059FC4}" type="datetimeFigureOut">
               <a:rPr lang="en-US" smtClean="0"/>
-              <a:t>10/30/2026</a:t>
+              <a:t>10/31/2026</a:t>
             </a:fld>
             <a:endParaRPr lang="en-US"/>
           </a:p>
@@ -4374,7 +4374,7 @@
           <a:p>
             <a:fld id="{5BCAD085-E8A6-8845-BD4E-CB4CCA059FC4}" type="datetimeFigureOut">
               <a:rPr lang="en-US" smtClean="0"/>
-              <a:t>10/30/2026</a:t>
+              <a:t>10/31/2026</a:t>
             </a:fld>
             <a:endParaRPr lang="en-US"/>
           </a:p>
@@ -4626,7 +4626,7 @@
           <a:p>
             <a:fld id="{5BCAD085-E8A6-8845-BD4E-CB4CCA059FC4}" type="datetimeFigureOut">
               <a:rPr lang="en-US" smtClean="0"/>
-              <a:t>10/30/2026</a:t>
+              <a:t>10/31/2026</a:t>
             </a:fld>
             <a:endParaRPr lang="en-US"/>
           </a:p>
@@ -4837,7 +4837,7 @@
           <a:p>
             <a:fld id="{5BCAD085-E8A6-8845-BD4E-CB4CCA059FC4}" type="datetimeFigureOut">
               <a:rPr lang="en-US" smtClean="0"/>
-              <a:t>10/30/2026</a:t>
+              <a:t>10/31/2026</a:t>
             </a:fld>
             <a:endParaRPr lang="en-US"/>
           </a:p>
@@ -29211,32 +29211,38 @@
           <p:cNvGraphicFramePr>
             <a:graphicFrameLocks noGrp="1"/>
           </p:cNvGraphicFramePr>
-          <p:nvPr/>
+          <p:nvPr>
+            <p:extLst>
+              <p:ext uri="{D42A27DB-BD31-4B8C-83A1-F6EECF244321}">
+                <p14:modId xmlns:p14="http://schemas.microsoft.com/office/powerpoint/2010/main" val="3824565726"/>
+              </p:ext>
+            </p:extLst>
+          </p:nvPr>
         </p:nvGraphicFramePr>
         <p:xfrm>
-          <a:off x="822745" y="1940948"/>
-          <a:ext cx="10548413" cy="2748804"/>
+          <a:off x="889236" y="1940947"/>
+          <a:ext cx="10481922" cy="3429556"/>
         </p:xfrm>
         <a:graphic>
           <a:graphicData uri="http://schemas.openxmlformats.org/drawingml/2006/table">
             <a:tbl>
               <a:tblPr/>
               <a:tblGrid>
-                <a:gridCol w="2320651">
+                <a:gridCol w="2298581">
                   <a:extLst>
                     <a:ext uri="{9D8B030D-6E8A-4147-A177-3AD203B41FA5}">
                       <a16:colId xmlns:a16="http://schemas.microsoft.com/office/drawing/2014/main" val="20000"/>
                     </a:ext>
                   </a:extLst>
                 </a:gridCol>
-                <a:gridCol w="3797429">
+                <a:gridCol w="3780934">
                   <a:extLst>
                     <a:ext uri="{9D8B030D-6E8A-4147-A177-3AD203B41FA5}">
                       <a16:colId xmlns:a16="http://schemas.microsoft.com/office/drawing/2014/main" val="20001"/>
                     </a:ext>
                   </a:extLst>
                 </a:gridCol>
-                <a:gridCol w="4430333">
+                <a:gridCol w="4402407">
                   <a:extLst>
                     <a:ext uri="{9D8B030D-6E8A-4147-A177-3AD203B41FA5}">
                       <a16:colId xmlns:a16="http://schemas.microsoft.com/office/drawing/2014/main" val="20002"/>
@@ -29244,7 +29250,7 @@
                   </a:extLst>
                 </a:gridCol>
               </a:tblGrid>
-              <a:tr h="356777">
+              <a:tr h="333872">
                 <a:tc>
                   <a:txBody>
                     <a:bodyPr/>
@@ -29464,7 +29470,7 @@
                   </a:ext>
                 </a:extLst>
               </a:tr>
-              <a:tr h="818937">
+              <a:tr h="766361">
                 <a:tc>
                   <a:txBody>
                     <a:bodyPr/>
@@ -29675,7 +29681,7 @@
                   </a:ext>
                 </a:extLst>
               </a:tr>
-              <a:tr h="786370">
+              <a:tr h="736049">
                 <a:tc>
                   <a:txBody>
                     <a:bodyPr/>
@@ -29886,7 +29892,7 @@
                   </a:ext>
                 </a:extLst>
               </a:tr>
-              <a:tr h="786370">
+              <a:tr h="736049">
                 <a:tc>
                   <a:txBody>
                     <a:bodyPr/>
@@ -30094,6 +30100,246 @@
                 <a:extLst>
                   <a:ext uri="{0D108BD9-81ED-4DB2-BD59-A6C34878D82A}">
                     <a16:rowId xmlns:a16="http://schemas.microsoft.com/office/drawing/2014/main" val="10003"/>
+                  </a:ext>
+                </a:extLst>
+              </a:tr>
+              <a:tr h="736049">
+                <a:tc>
+                  <a:txBody>
+                    <a:bodyPr/>
+                    <a:lstStyle/>
+                    <a:p>
+                      <a:pPr marL="0" indent="0">
+                        <a:lnSpc>
+                          <a:spcPts val="1820"/>
+                        </a:lnSpc>
+                        <a:buNone/>
+                      </a:pPr>
+                      <a:r>
+                        <a:rPr lang="en-US" sz="1300" kern="1200" dirty="0">
+                          <a:solidFill>
+                            <a:srgbClr val="F5B400"/>
+                          </a:solidFill>
+                          <a:latin typeface="Carlito" pitchFamily="34" charset="0"/>
+                          <a:ea typeface="Carlito" pitchFamily="34" charset="-122"/>
+                          <a:cs typeface="Carlito" charset="0"/>
+                        </a:rPr>
+                        <a:t>Retraining the models </a:t>
+                      </a:r>
+                      <a:r>
+                        <a:rPr lang="en-US" sz="1300" kern="1200">
+                          <a:solidFill>
+                            <a:srgbClr val="F5B400"/>
+                          </a:solidFill>
+                          <a:latin typeface="Carlito" pitchFamily="34" charset="0"/>
+                          <a:ea typeface="Carlito" pitchFamily="34" charset="-122"/>
+                          <a:cs typeface="Carlito" charset="0"/>
+                        </a:rPr>
+                        <a:t>again  and </a:t>
+                      </a:r>
+                      <a:r>
+                        <a:rPr lang="en-US" sz="1300" kern="1200" dirty="0">
+                          <a:solidFill>
+                            <a:srgbClr val="F5B400"/>
+                          </a:solidFill>
+                          <a:latin typeface="Carlito" pitchFamily="34" charset="0"/>
+                          <a:ea typeface="Carlito" pitchFamily="34" charset="-122"/>
+                          <a:cs typeface="Carlito" charset="0"/>
+                        </a:rPr>
+                        <a:t>again </a:t>
+                      </a:r>
+                    </a:p>
+                  </a:txBody>
+                  <a:tcPr marL="57770" marR="57770" marT="57770" marB="57770">
+                    <a:lnL w="12700" cap="flat" cmpd="sng" algn="ctr">
+                      <a:solidFill>
+                        <a:srgbClr val="3F5878"/>
+                      </a:solidFill>
+                      <a:prstDash val="solid"/>
+                      <a:round/>
+                      <a:headEnd type="none" w="med" len="med"/>
+                      <a:tailEnd type="none" w="med" len="med"/>
+                    </a:lnL>
+                    <a:lnR w="12700" cap="flat" cmpd="sng" algn="ctr">
+                      <a:solidFill>
+                        <a:srgbClr val="3F5878"/>
+                      </a:solidFill>
+                      <a:prstDash val="solid"/>
+                      <a:round/>
+                      <a:headEnd type="none" w="med" len="med"/>
+                      <a:tailEnd type="none" w="med" len="med"/>
+                    </a:lnR>
+                    <a:lnT w="12700" cap="flat" cmpd="sng" algn="ctr">
+                      <a:solidFill>
+                        <a:srgbClr val="3F5878"/>
+                      </a:solidFill>
+                      <a:prstDash val="solid"/>
+                      <a:round/>
+                      <a:headEnd type="none" w="med" len="med"/>
+                      <a:tailEnd type="none" w="med" len="med"/>
+                    </a:lnT>
+                    <a:lnB w="12700" cap="flat" cmpd="sng" algn="ctr">
+                      <a:solidFill>
+                        <a:srgbClr val="3F5878"/>
+                      </a:solidFill>
+                      <a:prstDash val="solid"/>
+                      <a:round/>
+                      <a:headEnd type="none" w="med" len="med"/>
+                      <a:tailEnd type="none" w="med" len="med"/>
+                    </a:lnB>
+                  </a:tcPr>
+                </a:tc>
+                <a:tc>
+                  <a:txBody>
+                    <a:bodyPr/>
+                    <a:lstStyle/>
+                    <a:p>
+                      <a:pPr marL="0" indent="0" algn="l" defTabSz="457200" rtl="0" eaLnBrk="1" latinLnBrk="0" hangingPunct="1">
+                        <a:lnSpc>
+                          <a:spcPts val="1820"/>
+                        </a:lnSpc>
+                        <a:buNone/>
+                      </a:pPr>
+                      <a:r>
+                        <a:rPr lang="en-US" sz="1300" kern="1200" dirty="0">
+                          <a:solidFill>
+                            <a:srgbClr val="DCE8F5"/>
+                          </a:solidFill>
+                          <a:latin typeface="Carlito" pitchFamily="34" charset="0"/>
+                          <a:ea typeface="Carlito" pitchFamily="34" charset="-122"/>
+                          <a:cs typeface="Carlito" charset="0"/>
+                        </a:rPr>
+                        <a:t>We realized there are some classes which are not getting identified and getting classified as others </a:t>
+                      </a:r>
+                    </a:p>
+                  </a:txBody>
+                  <a:tcPr marL="57770" marR="57770" marT="57770" marB="57770">
+                    <a:lnL w="12700" cap="flat" cmpd="sng" algn="ctr">
+                      <a:solidFill>
+                        <a:srgbClr val="3F5878"/>
+                      </a:solidFill>
+                      <a:prstDash val="solid"/>
+                      <a:round/>
+                      <a:headEnd type="none" w="med" len="med"/>
+                      <a:tailEnd type="none" w="med" len="med"/>
+                    </a:lnL>
+                    <a:lnR w="12700" cap="flat" cmpd="sng" algn="ctr">
+                      <a:solidFill>
+                        <a:srgbClr val="3F5878"/>
+                      </a:solidFill>
+                      <a:prstDash val="solid"/>
+                      <a:round/>
+                      <a:headEnd type="none" w="med" len="med"/>
+                      <a:tailEnd type="none" w="med" len="med"/>
+                    </a:lnR>
+                    <a:lnT w="12700" cap="flat" cmpd="sng" algn="ctr">
+                      <a:solidFill>
+                        <a:srgbClr val="3F5878"/>
+                      </a:solidFill>
+                      <a:prstDash val="solid"/>
+                      <a:round/>
+                      <a:headEnd type="none" w="med" len="med"/>
+                      <a:tailEnd type="none" w="med" len="med"/>
+                    </a:lnT>
+                    <a:lnB w="12700" cap="flat" cmpd="sng" algn="ctr">
+                      <a:solidFill>
+                        <a:srgbClr val="3F5878"/>
+                      </a:solidFill>
+                      <a:prstDash val="solid"/>
+                      <a:round/>
+                      <a:headEnd type="none" w="med" len="med"/>
+                      <a:tailEnd type="none" w="med" len="med"/>
+                    </a:lnB>
+                  </a:tcPr>
+                </a:tc>
+                <a:tc>
+                  <a:txBody>
+                    <a:bodyPr/>
+                    <a:lstStyle/>
+                    <a:p>
+                      <a:pPr marL="0" indent="0" algn="l" defTabSz="457200" rtl="0" eaLnBrk="1" latinLnBrk="0" hangingPunct="1">
+                        <a:lnSpc>
+                          <a:spcPts val="1820"/>
+                        </a:lnSpc>
+                        <a:buNone/>
+                      </a:pPr>
+                      <a:r>
+                        <a:rPr lang="en-US" sz="1300" kern="1200" dirty="0">
+                          <a:solidFill>
+                            <a:srgbClr val="8EE5B0"/>
+                          </a:solidFill>
+                          <a:latin typeface="Carlito" pitchFamily="34" charset="0"/>
+                          <a:ea typeface="Carlito" pitchFamily="34" charset="-122"/>
+                          <a:cs typeface="Carlito" charset="0"/>
+                        </a:rPr>
+                        <a:t>We create some custom video to train the model as per pour requirements </a:t>
+                      </a:r>
+                      <a:r>
+                        <a:rPr lang="en-US" sz="1300" kern="1200" dirty="0" err="1">
+                          <a:solidFill>
+                            <a:srgbClr val="8EE5B0"/>
+                          </a:solidFill>
+                          <a:latin typeface="Carlito" pitchFamily="34" charset="0"/>
+                          <a:ea typeface="Carlito" pitchFamily="34" charset="-122"/>
+                          <a:cs typeface="Carlito" charset="0"/>
+                        </a:rPr>
+                        <a:t>i.e</a:t>
+                      </a:r>
+                      <a:r>
+                        <a:rPr lang="en-US" sz="1300" kern="1200" dirty="0">
+                          <a:solidFill>
+                            <a:srgbClr val="8EE5B0"/>
+                          </a:solidFill>
+                          <a:latin typeface="Carlito" pitchFamily="34" charset="0"/>
+                          <a:ea typeface="Carlito" pitchFamily="34" charset="-122"/>
+                          <a:cs typeface="Carlito" charset="0"/>
+                        </a:rPr>
+                        <a:t> AWS videos and other app videos</a:t>
+                      </a:r>
+                    </a:p>
+                  </a:txBody>
+                  <a:tcPr marL="57770" marR="57770" marT="57770" marB="57770">
+                    <a:lnL w="12700" cap="flat" cmpd="sng" algn="ctr">
+                      <a:solidFill>
+                        <a:srgbClr val="3F5878"/>
+                      </a:solidFill>
+                      <a:prstDash val="solid"/>
+                      <a:round/>
+                      <a:headEnd type="none" w="med" len="med"/>
+                      <a:tailEnd type="none" w="med" len="med"/>
+                    </a:lnL>
+                    <a:lnR w="12700" cap="flat" cmpd="sng" algn="ctr">
+                      <a:solidFill>
+                        <a:srgbClr val="3F5878"/>
+                      </a:solidFill>
+                      <a:prstDash val="solid"/>
+                      <a:round/>
+                      <a:headEnd type="none" w="med" len="med"/>
+                      <a:tailEnd type="none" w="med" len="med"/>
+                    </a:lnR>
+                    <a:lnT w="12700" cap="flat" cmpd="sng" algn="ctr">
+                      <a:solidFill>
+                        <a:srgbClr val="3F5878"/>
+                      </a:solidFill>
+                      <a:prstDash val="solid"/>
+                      <a:round/>
+                      <a:headEnd type="none" w="med" len="med"/>
+                      <a:tailEnd type="none" w="med" len="med"/>
+                    </a:lnT>
+                    <a:lnB w="12700" cap="flat" cmpd="sng" algn="ctr">
+                      <a:solidFill>
+                        <a:srgbClr val="3F5878"/>
+                      </a:solidFill>
+                      <a:prstDash val="solid"/>
+                      <a:round/>
+                      <a:headEnd type="none" w="med" len="med"/>
+                      <a:tailEnd type="none" w="med" len="med"/>
+                    </a:lnB>
+                  </a:tcPr>
+                </a:tc>
+                <a:extLst>
+                  <a:ext uri="{0D108BD9-81ED-4DB2-BD59-A6C34878D82A}">
+                    <a16:rowId xmlns:a16="http://schemas.microsoft.com/office/drawing/2014/main" val="77475622"/>
                   </a:ext>
                 </a:extLst>
               </a:tr>

</xml_diff>